<commit_message>
docs: fix README inconsistencies and add GitHub Sponsors
</commit_message>
<xml_diff>
--- a/N3MO_Pitch_Deck_Premium.pptx
+++ b/N3MO_Pitch_Deck_Premium.pptx
@@ -12,6 +12,7 @@
     <p:sldId id="260" r:id="rId11"/>
     <p:sldId id="261" r:id="rId12"/>
     <p:sldId id="262" r:id="rId13"/>
+    <p:sldId id="263" r:id="rId14"/>
   </p:sldIdLst>
   <p:sldSz cx="14630400" cy="8229600" type="screen4x3"/>
   <p:notesSz cx="6858000" cy="9144000"/>
@@ -5297,6 +5298,501 @@
 </file>
 
 <file path=ppt/slides/slide7.xml><?xml version="1.0" encoding="utf-8"?>
+<p:sld xmlns:a="http://schemas.openxmlformats.org/drawingml/2006/main" xmlns:p="http://schemas.openxmlformats.org/presentationml/2006/main" xmlns:r="http://schemas.openxmlformats.org/officeDocument/2006/relationships">
+  <p:cSld>
+    <p:spTree>
+      <p:nvGrpSpPr>
+        <p:cNvPr id="1" name=""/>
+        <p:cNvGrpSpPr/>
+        <p:nvPr/>
+      </p:nvGrpSpPr>
+      <p:grpSpPr/>
+      <p:sp>
+        <p:nvSpPr>
+          <p:cNvPr id="2" name="Rectangle 1"/>
+          <p:cNvSpPr/>
+          <p:nvPr/>
+        </p:nvSpPr>
+        <p:spPr>
+          <a:xfrm>
+            <a:off x="0" y="0"/>
+            <a:ext cx="14630400" cy="8229600"/>
+          </a:xfrm>
+          <a:prstGeom prst="rect">
+            <a:avLst/>
+          </a:prstGeom>
+          <a:solidFill>
+            <a:srgbClr val="0F172A"/>
+          </a:solidFill>
+          <a:ln>
+            <a:noFill/>
+          </a:ln>
+        </p:spPr>
+        <p:style>
+          <a:lnRef idx="1">
+            <a:schemeClr val="accent1"/>
+          </a:lnRef>
+          <a:fillRef idx="3">
+            <a:schemeClr val="accent1"/>
+          </a:fillRef>
+          <a:effectRef idx="2">
+            <a:schemeClr val="accent1"/>
+          </a:effectRef>
+          <a:fontRef idx="minor">
+            <a:schemeClr val="lt1"/>
+          </a:fontRef>
+        </p:style>
+        <p:txBody>
+          <a:bodyPr rtlCol="0" anchor="ctr"/>
+          <a:lstStyle/>
+          <a:p>
+            <a:pPr algn="ctr"/>
+          </a:p>
+        </p:txBody>
+      </p:sp>
+      <p:sp>
+        <p:nvSpPr>
+          <p:cNvPr id="3" name="Rectangle 2"/>
+          <p:cNvSpPr/>
+          <p:nvPr/>
+        </p:nvSpPr>
+        <p:spPr>
+          <a:xfrm>
+            <a:off x="0" y="0"/>
+            <a:ext cx="7315200" cy="137160"/>
+          </a:xfrm>
+          <a:prstGeom prst="rect">
+            <a:avLst/>
+          </a:prstGeom>
+          <a:solidFill>
+            <a:srgbClr val="06B6D4"/>
+          </a:solidFill>
+          <a:ln>
+            <a:noFill/>
+          </a:ln>
+        </p:spPr>
+        <p:style>
+          <a:lnRef idx="1">
+            <a:schemeClr val="accent1"/>
+          </a:lnRef>
+          <a:fillRef idx="3">
+            <a:schemeClr val="accent1"/>
+          </a:fillRef>
+          <a:effectRef idx="2">
+            <a:schemeClr val="accent1"/>
+          </a:effectRef>
+          <a:fontRef idx="minor">
+            <a:schemeClr val="lt1"/>
+          </a:fontRef>
+        </p:style>
+        <p:txBody>
+          <a:bodyPr rtlCol="0" anchor="ctr"/>
+          <a:lstStyle/>
+          <a:p>
+            <a:pPr algn="ctr"/>
+          </a:p>
+        </p:txBody>
+      </p:sp>
+      <p:sp>
+        <p:nvSpPr>
+          <p:cNvPr id="4" name="Rectangle 3"/>
+          <p:cNvSpPr/>
+          <p:nvPr/>
+        </p:nvSpPr>
+        <p:spPr>
+          <a:xfrm>
+            <a:off x="7315200" y="0"/>
+            <a:ext cx="7315200" cy="137160"/>
+          </a:xfrm>
+          <a:prstGeom prst="rect">
+            <a:avLst/>
+          </a:prstGeom>
+          <a:solidFill>
+            <a:srgbClr val="A855F7"/>
+          </a:solidFill>
+          <a:ln>
+            <a:noFill/>
+          </a:ln>
+        </p:spPr>
+        <p:style>
+          <a:lnRef idx="1">
+            <a:schemeClr val="accent1"/>
+          </a:lnRef>
+          <a:fillRef idx="3">
+            <a:schemeClr val="accent1"/>
+          </a:fillRef>
+          <a:effectRef idx="2">
+            <a:schemeClr val="accent1"/>
+          </a:effectRef>
+          <a:fontRef idx="minor">
+            <a:schemeClr val="lt1"/>
+          </a:fontRef>
+        </p:style>
+        <p:txBody>
+          <a:bodyPr rtlCol="0" anchor="ctr"/>
+          <a:lstStyle/>
+          <a:p>
+            <a:pPr algn="ctr"/>
+          </a:p>
+        </p:txBody>
+      </p:sp>
+      <p:sp>
+        <p:nvSpPr>
+          <p:cNvPr id="5" name="TextBox 4"/>
+          <p:cNvSpPr txBox="1"/>
+          <p:nvPr/>
+        </p:nvSpPr>
+        <p:spPr>
+          <a:xfrm>
+            <a:off x="914400" y="731520"/>
+            <a:ext cx="12801600" cy="1371600"/>
+          </a:xfrm>
+          <a:prstGeom prst="rect">
+            <a:avLst/>
+          </a:prstGeom>
+          <a:noFill/>
+        </p:spPr>
+        <p:txBody>
+          <a:bodyPr wrap="none">
+            <a:spAutoFit/>
+          </a:bodyPr>
+          <a:lstStyle/>
+          <a:p>
+            <a:pPr>
+              <a:defRPr sz="5400" b="1">
+                <a:solidFill>
+                  <a:srgbClr val="F8FAFC"/>
+                </a:solidFill>
+                <a:latin typeface="Segoe UI"/>
+              </a:defRPr>
+            </a:pPr>
+            <a:r>
+              <a:t>Competitive Moat vs All-in-Ones</a:t>
+            </a:r>
+          </a:p>
+        </p:txBody>
+      </p:sp>
+      <p:sp>
+        <p:nvSpPr>
+          <p:cNvPr id="6" name="Rounded Rectangle 5"/>
+          <p:cNvSpPr/>
+          <p:nvPr/>
+        </p:nvSpPr>
+        <p:spPr>
+          <a:xfrm>
+            <a:off x="914400" y="2560320"/>
+            <a:ext cx="3931920" cy="4572000"/>
+          </a:xfrm>
+          <a:prstGeom prst="roundRect">
+            <a:avLst/>
+          </a:prstGeom>
+          <a:solidFill>
+            <a:srgbClr val="1E293B"/>
+          </a:solidFill>
+          <a:ln w="19050">
+            <a:solidFill>
+              <a:srgbClr val="06B6D4"/>
+            </a:solidFill>
+          </a:ln>
+        </p:spPr>
+        <p:style>
+          <a:lnRef idx="1">
+            <a:schemeClr val="accent1"/>
+          </a:lnRef>
+          <a:fillRef idx="3">
+            <a:schemeClr val="accent1"/>
+          </a:fillRef>
+          <a:effectRef idx="2">
+            <a:schemeClr val="accent1"/>
+          </a:effectRef>
+          <a:fontRef idx="minor">
+            <a:schemeClr val="lt1"/>
+          </a:fontRef>
+        </p:style>
+        <p:txBody>
+          <a:bodyPr rtlCol="0" anchor="ctr"/>
+          <a:lstStyle/>
+          <a:p>
+            <a:pPr algn="ctr"/>
+          </a:p>
+        </p:txBody>
+      </p:sp>
+      <p:sp>
+        <p:nvSpPr>
+          <p:cNvPr id="7" name="TextBox 6"/>
+          <p:cNvSpPr txBox="1"/>
+          <p:nvPr/>
+        </p:nvSpPr>
+        <p:spPr>
+          <a:xfrm>
+            <a:off x="1188720" y="2834640"/>
+            <a:ext cx="3383280" cy="4023360"/>
+          </a:xfrm>
+          <a:prstGeom prst="rect">
+            <a:avLst/>
+          </a:prstGeom>
+          <a:noFill/>
+        </p:spPr>
+        <p:txBody>
+          <a:bodyPr wrap="square">
+            <a:spAutoFit/>
+          </a:bodyPr>
+          <a:lstStyle/>
+          <a:p>
+            <a:pPr>
+              <a:defRPr sz="3200" b="1">
+                <a:solidFill>
+                  <a:srgbClr val="06B6D4"/>
+                </a:solidFill>
+                <a:latin typeface="Segoe UI"/>
+              </a:defRPr>
+            </a:pPr>
+            <a:r>
+              <a:t>Speed &amp; Focus</a:t>
+            </a:r>
+          </a:p>
+          <a:p>
+            <a:pPr>
+              <a:defRPr sz="2400">
+                <a:solidFill>
+                  <a:srgbClr val="F8FAFC"/>
+                </a:solidFill>
+                <a:latin typeface="Segoe UI"/>
+              </a:defRPr>
+            </a:pPr>
+          </a:p>
+          <a:p>
+            <a:pPr>
+              <a:defRPr sz="2400">
+                <a:solidFill>
+                  <a:srgbClr val="F8FAFC"/>
+                </a:solidFill>
+                <a:latin typeface="Segoe UI"/>
+              </a:defRPr>
+            </a:pPr>
+            <a:r>
+              <a:t>Unlike heavy platforms (Repowise, Sonar), N3MO does one thing perfectly: deterministic blast-radius mapping.</a:t>
+            </a:r>
+          </a:p>
+        </p:txBody>
+      </p:sp>
+      <p:sp>
+        <p:nvSpPr>
+          <p:cNvPr id="8" name="Rounded Rectangle 7"/>
+          <p:cNvSpPr/>
+          <p:nvPr/>
+        </p:nvSpPr>
+        <p:spPr>
+          <a:xfrm>
+            <a:off x="5212080" y="2560320"/>
+            <a:ext cx="3931920" cy="4572000"/>
+          </a:xfrm>
+          <a:prstGeom prst="roundRect">
+            <a:avLst/>
+          </a:prstGeom>
+          <a:solidFill>
+            <a:srgbClr val="1E293B"/>
+          </a:solidFill>
+          <a:ln w="19050">
+            <a:solidFill>
+              <a:srgbClr val="06B6D4"/>
+            </a:solidFill>
+          </a:ln>
+        </p:spPr>
+        <p:style>
+          <a:lnRef idx="1">
+            <a:schemeClr val="accent1"/>
+          </a:lnRef>
+          <a:fillRef idx="3">
+            <a:schemeClr val="accent1"/>
+          </a:fillRef>
+          <a:effectRef idx="2">
+            <a:schemeClr val="accent1"/>
+          </a:effectRef>
+          <a:fontRef idx="minor">
+            <a:schemeClr val="lt1"/>
+          </a:fontRef>
+        </p:style>
+        <p:txBody>
+          <a:bodyPr rtlCol="0" anchor="ctr"/>
+          <a:lstStyle/>
+          <a:p>
+            <a:pPr algn="ctr"/>
+          </a:p>
+        </p:txBody>
+      </p:sp>
+      <p:sp>
+        <p:nvSpPr>
+          <p:cNvPr id="9" name="TextBox 8"/>
+          <p:cNvSpPr txBox="1"/>
+          <p:nvPr/>
+        </p:nvSpPr>
+        <p:spPr>
+          <a:xfrm>
+            <a:off x="5486400" y="2834640"/>
+            <a:ext cx="3383280" cy="4023360"/>
+          </a:xfrm>
+          <a:prstGeom prst="rect">
+            <a:avLst/>
+          </a:prstGeom>
+          <a:noFill/>
+        </p:spPr>
+        <p:txBody>
+          <a:bodyPr wrap="square">
+            <a:spAutoFit/>
+          </a:bodyPr>
+          <a:lstStyle/>
+          <a:p>
+            <a:pPr>
+              <a:defRPr sz="3200" b="1">
+                <a:solidFill>
+                  <a:srgbClr val="06B6D4"/>
+                </a:solidFill>
+                <a:latin typeface="Segoe UI"/>
+              </a:defRPr>
+            </a:pPr>
+            <a:r>
+              <a:t>Zero Hallucination</a:t>
+            </a:r>
+          </a:p>
+          <a:p>
+            <a:pPr>
+              <a:defRPr sz="2400">
+                <a:solidFill>
+                  <a:srgbClr val="F8FAFC"/>
+                </a:solidFill>
+                <a:latin typeface="Segoe UI"/>
+              </a:defRPr>
+            </a:pPr>
+          </a:p>
+          <a:p>
+            <a:pPr>
+              <a:defRPr sz="2400">
+                <a:solidFill>
+                  <a:srgbClr val="F8FAFC"/>
+                </a:solidFill>
+                <a:latin typeface="Segoe UI"/>
+              </a:defRPr>
+            </a:pPr>
+            <a:r>
+              <a:t>Competitors use LLMs for analysis. N3MO uses pure math and ASTs—no drift, no embedding costs.</a:t>
+            </a:r>
+          </a:p>
+        </p:txBody>
+      </p:sp>
+      <p:sp>
+        <p:nvSpPr>
+          <p:cNvPr id="10" name="Rounded Rectangle 9"/>
+          <p:cNvSpPr/>
+          <p:nvPr/>
+        </p:nvSpPr>
+        <p:spPr>
+          <a:xfrm>
+            <a:off x="9509760" y="2560320"/>
+            <a:ext cx="3931920" cy="4572000"/>
+          </a:xfrm>
+          <a:prstGeom prst="roundRect">
+            <a:avLst/>
+          </a:prstGeom>
+          <a:solidFill>
+            <a:srgbClr val="1E293B"/>
+          </a:solidFill>
+          <a:ln w="19050">
+            <a:solidFill>
+              <a:srgbClr val="06B6D4"/>
+            </a:solidFill>
+          </a:ln>
+        </p:spPr>
+        <p:style>
+          <a:lnRef idx="1">
+            <a:schemeClr val="accent1"/>
+          </a:lnRef>
+          <a:fillRef idx="3">
+            <a:schemeClr val="accent1"/>
+          </a:fillRef>
+          <a:effectRef idx="2">
+            <a:schemeClr val="accent1"/>
+          </a:effectRef>
+          <a:fontRef idx="minor">
+            <a:schemeClr val="lt1"/>
+          </a:fontRef>
+        </p:style>
+        <p:txBody>
+          <a:bodyPr rtlCol="0" anchor="ctr"/>
+          <a:lstStyle/>
+          <a:p>
+            <a:pPr algn="ctr"/>
+          </a:p>
+        </p:txBody>
+      </p:sp>
+      <p:sp>
+        <p:nvSpPr>
+          <p:cNvPr id="11" name="TextBox 10"/>
+          <p:cNvSpPr txBox="1"/>
+          <p:nvPr/>
+        </p:nvSpPr>
+        <p:spPr>
+          <a:xfrm>
+            <a:off x="9784080" y="2834640"/>
+            <a:ext cx="3383280" cy="4023360"/>
+          </a:xfrm>
+          <a:prstGeom prst="rect">
+            <a:avLst/>
+          </a:prstGeom>
+          <a:noFill/>
+        </p:spPr>
+        <p:txBody>
+          <a:bodyPr wrap="square">
+            <a:spAutoFit/>
+          </a:bodyPr>
+          <a:lstStyle/>
+          <a:p>
+            <a:pPr>
+              <a:defRPr sz="3200" b="1">
+                <a:solidFill>
+                  <a:srgbClr val="06B6D4"/>
+                </a:solidFill>
+                <a:latin typeface="Segoe UI"/>
+              </a:defRPr>
+            </a:pPr>
+            <a:r>
+              <a:t>Frictionless CI/CD</a:t>
+            </a:r>
+          </a:p>
+          <a:p>
+            <a:pPr>
+              <a:defRPr sz="2400">
+                <a:solidFill>
+                  <a:srgbClr val="F8FAFC"/>
+                </a:solidFill>
+                <a:latin typeface="Segoe UI"/>
+              </a:defRPr>
+            </a:pPr>
+          </a:p>
+          <a:p>
+            <a:pPr>
+              <a:defRPr sz="2400">
+                <a:solidFill>
+                  <a:srgbClr val="F8FAFC"/>
+                </a:solidFill>
+                <a:latin typeface="Segoe UI"/>
+              </a:defRPr>
+            </a:pPr>
+            <a:r>
+              <a:t>N3MO targets the exact pain point: automatic PR webhooks with zero config. No local servers required.</a:t>
+            </a:r>
+          </a:p>
+        </p:txBody>
+      </p:sp>
+    </p:spTree>
+  </p:cSld>
+  <p:clrMapOvr>
+    <a:masterClrMapping/>
+  </p:clrMapOvr>
+</p:sld>
+</file>
+
+<file path=ppt/slides/slide8.xml><?xml version="1.0" encoding="utf-8"?>
 <p:sld xmlns:a="http://schemas.openxmlformats.org/drawingml/2006/main" xmlns:p="http://schemas.openxmlformats.org/presentationml/2006/main" xmlns:r="http://schemas.openxmlformats.org/officeDocument/2006/relationships">
   <p:cSld>
     <p:spTree>

</xml_diff>